<commit_message>
methods section fixed typo & add figure label
</commit_message>
<xml_diff>
--- a/poster/poster.pptx
+++ b/poster/poster.pptx
@@ -4286,10 +4286,10 @@
       </p:sp>
       <p:pic>
         <p:nvPicPr>
-          <p:cNvPr id="3" name="Picture 2" descr="A diagram of data processing&#10;&#10;AI-generated content may be incorrect.">
+          <p:cNvPr id="10" name="Picture 9" descr="A diagram of data processing&#10;&#10;AI-generated content may be incorrect.">
             <a:extLst>
               <a:ext uri="{FF2B5EF4-FFF2-40B4-BE49-F238E27FC236}">
-                <a16:creationId xmlns:a16="http://schemas.microsoft.com/office/drawing/2014/main" id="{C9FE7418-F660-2FD2-DACF-9AB0013F9E1D}"/>
+                <a16:creationId xmlns:a16="http://schemas.microsoft.com/office/drawing/2014/main" id="{18F87847-194C-83FD-1072-C41642607CE0}"/>
               </a:ext>
             </a:extLst>
           </p:cNvPr>
@@ -4306,14 +4306,50 @@
         </p:blipFill>
         <p:spPr>
           <a:xfrm>
-            <a:off x="12529018" y="5757996"/>
-            <a:ext cx="18851724" cy="10878185"/>
+            <a:off x="12563720" y="5688035"/>
+            <a:ext cx="18772064" cy="10454641"/>
           </a:xfrm>
           <a:prstGeom prst="rect">
             <a:avLst/>
           </a:prstGeom>
         </p:spPr>
       </p:pic>
+      <p:sp>
+        <p:nvSpPr>
+          <p:cNvPr id="13" name="TextBox 12">
+            <a:extLst>
+              <a:ext uri="{FF2B5EF4-FFF2-40B4-BE49-F238E27FC236}">
+                <a16:creationId xmlns:a16="http://schemas.microsoft.com/office/drawing/2014/main" id="{32B2F649-BCDA-7730-B6AF-C35252EE1F64}"/>
+              </a:ext>
+            </a:extLst>
+          </p:cNvPr>
+          <p:cNvSpPr txBox="1"/>
+          <p:nvPr/>
+        </p:nvSpPr>
+        <p:spPr>
+          <a:xfrm>
+            <a:off x="12563720" y="16213014"/>
+            <a:ext cx="18772064" cy="615553"/>
+          </a:xfrm>
+          <a:prstGeom prst="rect">
+            <a:avLst/>
+          </a:prstGeom>
+          <a:noFill/>
+        </p:spPr>
+        <p:txBody>
+          <a:bodyPr wrap="square" rtlCol="0">
+            <a:spAutoFit/>
+          </a:bodyPr>
+          <a:lstStyle/>
+          <a:p>
+            <a:pPr algn="ctr"/>
+            <a:r>
+              <a:rPr lang="en-CA" sz="3400" dirty="0"/>
+              <a:t>Figure 1: Flow chart of data wrangling architecture</a:t>
+            </a:r>
+          </a:p>
+        </p:txBody>
+      </p:sp>
     </p:spTree>
     <p:extLst>
       <p:ext uri="{BB962C8B-B14F-4D97-AF65-F5344CB8AC3E}">

</xml_diff>

<commit_message>
Update Conclusions & Impact section
</commit_message>
<xml_diff>
--- a/poster/poster.pptx
+++ b/poster/poster.pptx
@@ -3633,16 +3633,56 @@
           <a:lstStyle/>
           <a:p>
             <a:r>
-              <a:rPr lang="en-CA" sz="3400" b="1" dirty="0">
-                <a:solidFill>
-                  <a:schemeClr val="tx1"/>
-                </a:solidFill>
-              </a:rPr>
-              <a:t>Key Takeaway: Male patients with high BMI and high glucose may benefit from closer postoperative monitoring for early detection and timely intervention of hypoxemia.</a:t>
-            </a:r>
-          </a:p>
-          <a:p>
-            <a:endParaRPr lang="en-CA" sz="3400" b="1" dirty="0">
+              <a:rPr lang="en-CA" sz="3600" b="1" dirty="0">
+                <a:solidFill>
+                  <a:schemeClr val="tx1"/>
+                </a:solidFill>
+              </a:rPr>
+              <a:t>Key Takeaway: </a:t>
+            </a:r>
+            <a:r>
+              <a:rPr lang="en-CA" sz="3600" dirty="0">
+                <a:solidFill>
+                  <a:schemeClr val="tx1"/>
+                </a:solidFill>
+              </a:rPr>
+              <a:t>Patients who are </a:t>
+            </a:r>
+            <a:r>
+              <a:rPr lang="en-CA" sz="3600" b="1" dirty="0">
+                <a:solidFill>
+                  <a:schemeClr val="tx1"/>
+                </a:solidFill>
+              </a:rPr>
+              <a:t>male</a:t>
+            </a:r>
+            <a:r>
+              <a:rPr lang="en-CA" sz="3600" dirty="0">
+                <a:solidFill>
+                  <a:schemeClr val="tx1"/>
+                </a:solidFill>
+              </a:rPr>
+              <a:t> or </a:t>
+            </a:r>
+            <a:r>
+              <a:rPr lang="en-CA" sz="3600" b="1" dirty="0">
+                <a:solidFill>
+                  <a:schemeClr val="tx1"/>
+                </a:solidFill>
+              </a:rPr>
+              <a:t>have high BMI </a:t>
+            </a:r>
+            <a:r>
+              <a:rPr lang="en-CA" sz="3600" dirty="0">
+                <a:solidFill>
+                  <a:schemeClr val="tx1"/>
+                </a:solidFill>
+              </a:rPr>
+              <a:t>may benefit from closer postoperative monitoring for timely detection and intervention of hypoxemia</a:t>
+            </a:r>
+          </a:p>
+          <a:p>
+            <a:endParaRPr lang="en-CA" sz="3600" b="1" dirty="0">
               <a:solidFill>
                 <a:schemeClr val="tx1"/>
               </a:solidFill>
@@ -3650,7 +3690,7 @@
           </a:p>
           <a:p>
             <a:r>
-              <a:rPr lang="en-CA" sz="3400" b="1" dirty="0">
+              <a:rPr lang="en-CA" sz="3600" b="1" dirty="0">
                 <a:solidFill>
                   <a:schemeClr val="tx1"/>
                 </a:solidFill>
@@ -3664,7 +3704,7 @@
               <a:buChar char="•"/>
             </a:pPr>
             <a:r>
-              <a:rPr lang="en-CA" sz="3400" b="1" dirty="0">
+              <a:rPr lang="en-CA" sz="3600" b="1" dirty="0">
                 <a:solidFill>
                   <a:schemeClr val="tx1"/>
                 </a:solidFill>
@@ -3672,7 +3712,7 @@
               <a:t>Higher BMI </a:t>
             </a:r>
             <a:r>
-              <a:rPr lang="en-CA" sz="3400" dirty="0">
+              <a:rPr lang="en-CA" sz="3600" dirty="0">
                 <a:solidFill>
                   <a:schemeClr val="tx1"/>
                 </a:solidFill>
@@ -3680,15 +3720,15 @@
               <a:t>elevates odds of </a:t>
             </a:r>
             <a:r>
-              <a:rPr lang="en-US" sz="3400" dirty="0">
-                <a:solidFill>
-                  <a:schemeClr val="tx1"/>
-                </a:solidFill>
-              </a:rPr>
-              <a:t>postoperative hypoxemia , </a:t>
-            </a:r>
-            <a:r>
-              <a:rPr lang="en-CA" sz="3400" dirty="0">
+              <a:rPr lang="en-US" sz="3600" dirty="0">
+                <a:solidFill>
+                  <a:schemeClr val="tx1"/>
+                </a:solidFill>
+              </a:rPr>
+              <a:t>postoperative hypoxemia, </a:t>
+            </a:r>
+            <a:r>
+              <a:rPr lang="en-CA" sz="3600" dirty="0">
                 <a:solidFill>
                   <a:schemeClr val="tx1"/>
                 </a:solidFill>
@@ -3696,7 +3736,7 @@
               <a:t>aligning with established literature</a:t>
             </a:r>
             <a:r>
-              <a:rPr lang="en-CA" sz="3400" baseline="30000" dirty="0">
+              <a:rPr lang="en-CA" sz="3600" baseline="30000" dirty="0">
                 <a:solidFill>
                   <a:schemeClr val="tx1"/>
                 </a:solidFill>
@@ -3710,20 +3750,45 @@
               <a:buChar char="•"/>
             </a:pPr>
             <a:r>
-              <a:rPr lang="en-CA" sz="3400" b="1" dirty="0">
-                <a:solidFill>
-                  <a:schemeClr val="tx1"/>
-                </a:solidFill>
-              </a:rPr>
-              <a:t>Higher glucose level </a:t>
-            </a:r>
-            <a:r>
-              <a:rPr lang="en-CA" sz="3400" dirty="0">
-                <a:solidFill>
-                  <a:schemeClr val="tx1"/>
-                </a:solidFill>
-              </a:rPr>
-              <a:t>were significantly associated with increased odds of hypoxemia</a:t>
+              <a:rPr lang="en-CA" sz="3600" b="1" dirty="0">
+                <a:solidFill>
+                  <a:schemeClr val="tx1"/>
+                </a:solidFill>
+              </a:rPr>
+              <a:t>Male</a:t>
+            </a:r>
+            <a:r>
+              <a:rPr lang="en-CA" sz="3600" dirty="0">
+                <a:solidFill>
+                  <a:schemeClr val="tx1"/>
+                </a:solidFill>
+              </a:rPr>
+              <a:t> patients have higher odds of hypoxemia, which contradicts previous findings that showed being female as a risk factor</a:t>
+            </a:r>
+            <a:r>
+              <a:rPr lang="en-CA" sz="3600" baseline="30000" dirty="0">
+                <a:solidFill>
+                  <a:schemeClr val="tx1"/>
+                </a:solidFill>
+              </a:rPr>
+              <a:t>4</a:t>
+            </a:r>
+          </a:p>
+          <a:p>
+            <a:endParaRPr lang="en-CA" sz="3600" baseline="30000" dirty="0">
+              <a:solidFill>
+                <a:schemeClr val="tx1"/>
+              </a:solidFill>
+            </a:endParaRPr>
+          </a:p>
+          <a:p>
+            <a:r>
+              <a:rPr lang="en-CA" sz="3600" b="1" dirty="0">
+                <a:solidFill>
+                  <a:schemeClr val="tx1"/>
+                </a:solidFill>
+              </a:rPr>
+              <a:t>Model Performance and Limitation</a:t>
             </a:r>
           </a:p>
           <a:p>
@@ -3732,32 +3797,50 @@
               <a:buChar char="•"/>
             </a:pPr>
             <a:r>
-              <a:rPr lang="en-CA" sz="3400" b="1" dirty="0">
-                <a:solidFill>
-                  <a:schemeClr val="tx1"/>
-                </a:solidFill>
-              </a:rPr>
-              <a:t>Male</a:t>
-            </a:r>
-            <a:r>
-              <a:rPr lang="en-CA" sz="3400" dirty="0">
-                <a:solidFill>
-                  <a:schemeClr val="tx1"/>
-                </a:solidFill>
-              </a:rPr>
-              <a:t> patients have higher odds of hypoxemia, which contradicts previous findings that showed being female as a risk factor</a:t>
-            </a:r>
-            <a:r>
-              <a:rPr lang="en-CA" sz="3400" baseline="30000" dirty="0">
-                <a:solidFill>
-                  <a:schemeClr val="tx1"/>
-                </a:solidFill>
-              </a:rPr>
-              <a:t>4</a:t>
-            </a:r>
-          </a:p>
-          <a:p>
-            <a:endParaRPr lang="en-CA" sz="3400" baseline="30000" dirty="0">
+              <a:rPr lang="en-CA" sz="3600" dirty="0">
+                <a:solidFill>
+                  <a:schemeClr val="tx1"/>
+                </a:solidFill>
+              </a:rPr>
+              <a:t>The reduced model achieved a lower test set misclassification rate (28%) than the full model (29%), suggesting that additional demographic and lab test variables introduced noise rather than clinical signal</a:t>
+            </a:r>
+          </a:p>
+          <a:p>
+            <a:pPr marL="571500" indent="-571500">
+              <a:buFont typeface="Arial" panose="020B0604020202020204" pitchFamily="34" charset="0"/>
+              <a:buChar char="•"/>
+            </a:pPr>
+            <a:r>
+              <a:rPr lang="en-CA" sz="3600" dirty="0">
+                <a:solidFill>
+                  <a:schemeClr val="tx1"/>
+                </a:solidFill>
+              </a:rPr>
+              <a:t>Only 98 out of 24,167 patients (0.4%) had hypoxemia. This extreme class imbalance remains a challenge for clinical application, as the high misclassification rate persisted despite </a:t>
+            </a:r>
+            <a:r>
+              <a:rPr lang="en-CA" sz="3600" dirty="0" err="1">
+                <a:solidFill>
+                  <a:schemeClr val="tx1"/>
+                </a:solidFill>
+              </a:rPr>
+              <a:t>undersampling</a:t>
+            </a:r>
+            <a:r>
+              <a:rPr lang="en-CA" sz="3600" dirty="0">
+                <a:solidFill>
+                  <a:schemeClr val="tx1"/>
+                </a:solidFill>
+              </a:rPr>
+              <a:t> control cases to balance the data</a:t>
+            </a:r>
+          </a:p>
+          <a:p>
+            <a:pPr marL="571500" indent="-571500">
+              <a:buFont typeface="Arial" panose="020B0604020202020204" pitchFamily="34" charset="0"/>
+              <a:buChar char="•"/>
+            </a:pPr>
+            <a:endParaRPr lang="en-CA" sz="3600" dirty="0">
               <a:solidFill>
                 <a:schemeClr val="tx1"/>
               </a:solidFill>
@@ -3765,12 +3848,12 @@
           </a:p>
           <a:p>
             <a:r>
-              <a:rPr lang="en-CA" sz="3400" b="1" dirty="0">
-                <a:solidFill>
-                  <a:schemeClr val="tx1"/>
-                </a:solidFill>
-              </a:rPr>
-              <a:t>Model Performance and Limitation</a:t>
+              <a:rPr lang="en-CA" sz="3600" b="1" dirty="0">
+                <a:solidFill>
+                  <a:schemeClr val="tx1"/>
+                </a:solidFill>
+              </a:rPr>
+              <a:t>Future Directions</a:t>
             </a:r>
           </a:p>
           <a:p>
@@ -3779,12 +3862,44 @@
               <a:buChar char="•"/>
             </a:pPr>
             <a:r>
-              <a:rPr lang="en-CA" sz="3400" dirty="0">
-                <a:solidFill>
-                  <a:schemeClr val="tx1"/>
-                </a:solidFill>
-              </a:rPr>
-              <a:t>The full model achieved a lower test misclassification rate (37%) than the reduced model (43%), suggesting that including a broader set of lab test results is necessary to capture the complexity of hypoxemia</a:t>
+              <a:rPr lang="en-CA" sz="3600" dirty="0">
+                <a:solidFill>
+                  <a:schemeClr val="tx1"/>
+                </a:solidFill>
+              </a:rPr>
+              <a:t>Employing</a:t>
+            </a:r>
+            <a:r>
+              <a:rPr lang="en-CA" sz="3600" b="1" dirty="0">
+                <a:solidFill>
+                  <a:schemeClr val="tx1"/>
+                </a:solidFill>
+              </a:rPr>
+              <a:t> </a:t>
+            </a:r>
+            <a:r>
+              <a:rPr lang="en-CA" sz="3600" dirty="0">
+                <a:solidFill>
+                  <a:schemeClr val="tx1"/>
+                </a:solidFill>
+              </a:rPr>
+              <a:t>systematic</a:t>
+            </a:r>
+            <a:r>
+              <a:rPr lang="en-CA" sz="3600" b="1" dirty="0">
+                <a:solidFill>
+                  <a:schemeClr val="tx1"/>
+                </a:solidFill>
+              </a:rPr>
+              <a:t> </a:t>
+            </a:r>
+            <a:r>
+              <a:rPr lang="en-CA" sz="3600" dirty="0">
+                <a:solidFill>
+                  <a:schemeClr val="tx1"/>
+                </a:solidFill>
+              </a:rPr>
+              <a:t>oversampling or re-weighting techniques to improve minority class classification</a:t>
             </a:r>
           </a:p>
           <a:p>
@@ -3793,115 +3908,12 @@
               <a:buChar char="•"/>
             </a:pPr>
             <a:r>
-              <a:rPr lang="en-CA" sz="3400" dirty="0">
-                <a:solidFill>
-                  <a:schemeClr val="tx1"/>
-                </a:solidFill>
-              </a:rPr>
-              <a:t>Only </a:t>
-            </a:r>
-            <a:r>
-              <a:rPr lang="en-CA" sz="3400" dirty="0">
-                <a:solidFill>
-                  <a:schemeClr val="tx1"/>
-                </a:solidFill>
-                <a:highlight>
-                  <a:srgbClr val="FFFF00"/>
-                </a:highlight>
-              </a:rPr>
-              <a:t>[percentage]% </a:t>
-            </a:r>
-            <a:r>
-              <a:rPr lang="en-CA" sz="3400" dirty="0">
-                <a:solidFill>
-                  <a:schemeClr val="tx1"/>
-                </a:solidFill>
-              </a:rPr>
-              <a:t>of patients reported postoperative hypoxemia, likely contributing to the relatively high misclassification rate</a:t>
-            </a:r>
-          </a:p>
-          <a:p>
-            <a:endParaRPr lang="en-CA" sz="3400" dirty="0">
-              <a:solidFill>
-                <a:schemeClr val="tx1"/>
-              </a:solidFill>
-            </a:endParaRPr>
-          </a:p>
-          <a:p>
-            <a:r>
-              <a:rPr lang="en-CA" sz="3400" b="1" dirty="0">
-                <a:solidFill>
-                  <a:schemeClr val="tx1"/>
-                </a:solidFill>
-              </a:rPr>
-              <a:t>Future Directions</a:t>
-            </a:r>
-          </a:p>
-          <a:p>
-            <a:pPr marL="571500" indent="-571500">
-              <a:buFont typeface="Arial" panose="020B0604020202020204" pitchFamily="34" charset="0"/>
-              <a:buChar char="•"/>
-            </a:pPr>
-            <a:r>
-              <a:rPr lang="en-CA" sz="3400" dirty="0">
-                <a:solidFill>
-                  <a:schemeClr val="tx1"/>
-                </a:solidFill>
-              </a:rPr>
-              <a:t>Employing</a:t>
-            </a:r>
-            <a:r>
-              <a:rPr lang="en-CA" sz="3400" b="1" dirty="0">
-                <a:solidFill>
-                  <a:schemeClr val="tx1"/>
-                </a:solidFill>
-              </a:rPr>
-              <a:t> </a:t>
-            </a:r>
-            <a:r>
-              <a:rPr lang="en-CA" sz="3400" dirty="0">
-                <a:solidFill>
-                  <a:schemeClr val="tx1"/>
-                </a:solidFill>
-              </a:rPr>
-              <a:t>oversampling or re-weighting techniques to better account for imbalance and improve predictive accuracy</a:t>
-            </a:r>
-            <a:r>
-              <a:rPr lang="en-CA" sz="3400" dirty="0"/>
-              <a:t>.</a:t>
-            </a:r>
-            <a:endParaRPr lang="en-CA" sz="3400" dirty="0">
-              <a:solidFill>
-                <a:schemeClr val="tx1"/>
-              </a:solidFill>
-            </a:endParaRPr>
-          </a:p>
-          <a:p>
-            <a:pPr marL="571500" indent="-571500">
-              <a:buFont typeface="Arial" panose="020B0604020202020204" pitchFamily="34" charset="0"/>
-              <a:buChar char="•"/>
-            </a:pPr>
-            <a:r>
-              <a:rPr lang="en-CA" sz="3400" dirty="0">
-                <a:solidFill>
-                  <a:schemeClr val="tx1"/>
-                </a:solidFill>
-              </a:rPr>
-              <a:t>Incorporating a wider variety of laboratory tests to strengthen predictive power</a:t>
-            </a:r>
-          </a:p>
-          <a:p>
-            <a:pPr marL="571500" indent="-571500">
-              <a:buFont typeface="Arial" panose="020B0604020202020204" pitchFamily="34" charset="0"/>
-              <a:buChar char="•"/>
-            </a:pPr>
-            <a:r>
-              <a:rPr lang="en-CA" sz="3400" dirty="0">
-                <a:solidFill>
-                  <a:schemeClr val="tx1"/>
-                </a:solidFill>
-              </a:rPr>
-              <a:t>Exploring how hypoxemia interacts with other concurrent postoperative complications</a:t>
+              <a:rPr lang="en-CA" sz="3600" dirty="0">
+                <a:solidFill>
+                  <a:schemeClr val="tx1"/>
+                </a:solidFill>
+              </a:rPr>
+              <a:t>Exploring alternative biomarkers, lab tests and the interplay between hypoxemia and other concurrent postoperative complications to enhance predictive accuracy</a:t>
             </a:r>
           </a:p>
         </p:txBody>

</xml_diff>

<commit_message>
Updated findings and conclusions
</commit_message>
<xml_diff>
--- a/poster/poster.pptx
+++ b/poster/poster.pptx
@@ -3695,7 +3695,7 @@
                   <a:schemeClr val="tx1"/>
                 </a:solidFill>
               </a:rPr>
-              <a:t>Key Risk Factors</a:t>
+              <a:t>Key Risk Factors of Postoperative hypoxemia</a:t>
             </a:r>
           </a:p>
           <a:p>
@@ -3717,7 +3717,7 @@
                   <a:schemeClr val="tx1"/>
                 </a:solidFill>
               </a:rPr>
-              <a:t>elevates odds of </a:t>
+              <a:t>elevates odds</a:t>
             </a:r>
             <a:r>
               <a:rPr lang="en-US" sz="3600" dirty="0">
@@ -3725,7 +3725,7 @@
                   <a:schemeClr val="tx1"/>
                 </a:solidFill>
               </a:rPr>
-              <a:t>postoperative hypoxemia, </a:t>
+              <a:t>, </a:t>
             </a:r>
             <a:r>
               <a:rPr lang="en-CA" sz="3600" dirty="0">
@@ -3750,12 +3750,20 @@
               <a:buChar char="•"/>
             </a:pPr>
             <a:r>
+              <a:rPr lang="en-CA" sz="3600" dirty="0">
+                <a:solidFill>
+                  <a:schemeClr val="tx1"/>
+                </a:solidFill>
+              </a:rPr>
+              <a:t>Higher odds among </a:t>
+            </a:r>
+            <a:r>
               <a:rPr lang="en-CA" sz="3600" b="1" dirty="0">
                 <a:solidFill>
                   <a:schemeClr val="tx1"/>
                 </a:solidFill>
               </a:rPr>
-              <a:t>Male</a:t>
+              <a:t>males, </a:t>
             </a:r>
             <a:r>
               <a:rPr lang="en-CA" sz="3600" dirty="0">
@@ -3763,7 +3771,7 @@
                   <a:schemeClr val="tx1"/>
                 </a:solidFill>
               </a:rPr>
-              <a:t> patients have higher odds of hypoxemia, which contradicts previous findings that showed being female as a risk factor</a:t>
+              <a:t>contradicting previous findings</a:t>
             </a:r>
             <a:r>
               <a:rPr lang="en-CA" sz="3600" baseline="30000" dirty="0">
@@ -3802,7 +3810,7 @@
                   <a:schemeClr val="tx1"/>
                 </a:solidFill>
               </a:rPr>
-              <a:t>The reduced model achieved a lower test set misclassification rate (28%) than the full model (29%), suggesting that additional demographic and lab test variables introduced noise rather than clinical signal</a:t>
+              <a:t>The reduced model outperforms the full model, suggesting that additional variables introduced noise rather than clinical signal</a:t>
             </a:r>
           </a:p>
           <a:p>
@@ -3816,7 +3824,7 @@
                   <a:schemeClr val="tx1"/>
                 </a:solidFill>
               </a:rPr>
-              <a:t>Only 98 out of 24,167 patients (0.4%) had hypoxemia. This extreme class imbalance remains a challenge for clinical application, as the high misclassification rate persisted despite </a:t>
+              <a:t>Only 98 out of 24,167 patients (0.4%) had hypoxemia. This extreme class imbalance limited model performance despite </a:t>
             </a:r>
             <a:r>
               <a:rPr lang="en-CA" sz="3600" dirty="0" err="1">
@@ -3913,7 +3921,7 @@
                   <a:schemeClr val="tx1"/>
                 </a:solidFill>
               </a:rPr>
-              <a:t>Exploring alternative biomarkers, lab tests and the interplay between hypoxemia and other concurrent postoperative complications to enhance predictive accuracy</a:t>
+              <a:t>Investigating alternative biomarkers and the interplay between hypoxemia and concurrent postoperative complications to enhance predictive accuracy</a:t>
             </a:r>
           </a:p>
         </p:txBody>
@@ -4443,7 +4451,7 @@
         <p:spPr>
           <a:xfrm>
             <a:off x="24190338" y="19473081"/>
-            <a:ext cx="7200000" cy="9000000"/>
+            <a:ext cx="7200000" cy="7540526"/>
           </a:xfrm>
           <a:prstGeom prst="rect">
             <a:avLst/>
@@ -4462,7 +4470,24 @@
             </a:pPr>
             <a:r>
               <a:rPr lang="en-CA" sz="4400" dirty="0"/>
-              <a:t>Table 1 presents the full logistic regression model results. In the full model, sex and body mass index were the only predictors significant at the 0.05 level, with female sex associated with lower odds of postoperative hypoxemia and higher body mass index associated with higher odds.</a:t>
+              <a:t>In the full model, sex and body mass index were the only predictors significant at the 0.05 level (Table 1).</a:t>
+            </a:r>
+          </a:p>
+          <a:p>
+            <a:pPr marL="571500" indent="-571500">
+              <a:buFont typeface="Arial" panose="020B0604020202020204" pitchFamily="34" charset="0"/>
+              <a:buChar char="•"/>
+            </a:pPr>
+            <a:endParaRPr lang="en-CA" sz="4400" dirty="0"/>
+          </a:p>
+          <a:p>
+            <a:pPr marL="571500" indent="-571500">
+              <a:buFont typeface="Arial" panose="020B0604020202020204" pitchFamily="34" charset="0"/>
+              <a:buChar char="•"/>
+            </a:pPr>
+            <a:r>
+              <a:rPr lang="en-CA" sz="4400" dirty="0"/>
+              <a:t>Female sex is associated with lower odds of postoperative hypoxemia and higher body mass index associated with higher odds.</a:t>
             </a:r>
           </a:p>
         </p:txBody>
@@ -4482,7 +4507,7 @@
         <p:spPr>
           <a:xfrm>
             <a:off x="12405359" y="29429787"/>
-            <a:ext cx="19080479" cy="2523768"/>
+            <a:ext cx="19080479" cy="1323439"/>
           </a:xfrm>
           <a:prstGeom prst="rect">
             <a:avLst/>
@@ -4500,9 +4525,10 @@
               <a:buChar char="•"/>
             </a:pPr>
             <a:r>
-              <a:rPr lang="en-CA" sz="3950" dirty="0"/>
-              <a:t>On the test set, the full model had a misclassification error rate of 0.293 (29.3%), while the reduced model, which included only the predictors that were significant in the full model, had a misclassification error rate of 0.28 (28.0%). Thus, the reduced model showed slightly better predictive performance than the full model in this sample.</a:t>
-            </a:r>
+              <a:rPr lang="en-CA" sz="4000" dirty="0"/>
+              <a:t>The reduced model, which included only sex and body mass index, achieved a lower test set misclassification rate (28.0%) than the full model (29.3%).</a:t>
+            </a:r>
+            <a:endParaRPr lang="en-CA" sz="3950" dirty="0"/>
           </a:p>
         </p:txBody>
       </p:sp>

</xml_diff>

<commit_message>
Update poster to include Abstract & finalize
</commit_message>
<xml_diff>
--- a/poster/poster.pptx
+++ b/poster/poster.pptx
@@ -3032,7 +3032,55 @@
                   <a:schemeClr val="bg1"/>
                 </a:solidFill>
               </a:rPr>
-              <a:t>Authors</a:t>
+              <a:t>Yunfei Yu</a:t>
+            </a:r>
+            <a:r>
+              <a:rPr lang="en-US" sz="5400" b="1" baseline="30000" dirty="0">
+                <a:solidFill>
+                  <a:schemeClr val="bg1"/>
+                </a:solidFill>
+              </a:rPr>
+              <a:t>1</a:t>
+            </a:r>
+            <a:r>
+              <a:rPr lang="en-US" sz="5400" b="1" dirty="0">
+                <a:solidFill>
+                  <a:schemeClr val="bg1"/>
+                </a:solidFill>
+              </a:rPr>
+              <a:t>, Yang Lei</a:t>
+            </a:r>
+            <a:r>
+              <a:rPr lang="en-US" sz="5400" b="1" baseline="30000" dirty="0">
+                <a:solidFill>
+                  <a:schemeClr val="bg1"/>
+                </a:solidFill>
+              </a:rPr>
+              <a:t>1</a:t>
+            </a:r>
+            <a:r>
+              <a:rPr lang="en-US" sz="5400" b="1" dirty="0">
+                <a:solidFill>
+                  <a:schemeClr val="bg1"/>
+                </a:solidFill>
+              </a:rPr>
+              <a:t>, Benny Rochwerg</a:t>
+            </a:r>
+            <a:r>
+              <a:rPr lang="en-US" sz="5400" b="1" baseline="30000" dirty="0">
+                <a:solidFill>
+                  <a:schemeClr val="bg1"/>
+                </a:solidFill>
+              </a:rPr>
+              <a:t>1</a:t>
+            </a:r>
+            <a:r>
+              <a:rPr lang="en-US" sz="5400" b="1" dirty="0">
+                <a:solidFill>
+                  <a:schemeClr val="bg1"/>
+                </a:solidFill>
+              </a:rPr>
+              <a:t>, &amp; Camellia Zakaria</a:t>
             </a:r>
             <a:r>
               <a:rPr lang="en-US" sz="5400" b="1" baseline="30000" dirty="0">
@@ -3133,7 +3181,7 @@
         <p:spPr>
           <a:xfrm>
             <a:off x="0" y="5547360"/>
-            <a:ext cx="11765280" cy="5913120"/>
+            <a:ext cx="11765280" cy="12371672"/>
           </a:xfrm>
           <a:prstGeom prst="rect">
             <a:avLst/>
@@ -3163,12 +3211,124 @@
           <a:bodyPr rtlCol="0" anchor="ctr"/>
           <a:lstStyle/>
           <a:p>
-            <a:pPr algn="ctr"/>
-            <a:endParaRPr lang="en-US" sz="5400" b="1" dirty="0">
+            <a:pPr marL="571500" indent="-571500">
+              <a:buFont typeface="Arial" panose="020B0604020202020204" pitchFamily="34" charset="0"/>
+              <a:buChar char="•"/>
+            </a:pPr>
+            <a:r>
+              <a:rPr lang="en-US" sz="3600" dirty="0">
+                <a:solidFill>
+                  <a:schemeClr val="tx1"/>
+                </a:solidFill>
+              </a:rPr>
+              <a:t>MOVER data were wrangled to find significant predictors of postoperative hypoxemia using a full logistic regression model</a:t>
+            </a:r>
+          </a:p>
+          <a:p>
+            <a:pPr marL="1028700" lvl="1" indent="-571500">
+              <a:buFont typeface="Arial" panose="020B0604020202020204" pitchFamily="34" charset="0"/>
+              <a:buChar char="•"/>
+            </a:pPr>
+            <a:r>
+              <a:rPr lang="en-US" sz="3600" dirty="0">
+                <a:solidFill>
+                  <a:schemeClr val="tx1"/>
+                </a:solidFill>
+              </a:rPr>
+              <a:t>Male sex and higher body mass index (BMI) were identified</a:t>
+            </a:r>
+            <a:br>
+              <a:rPr lang="en-US" sz="3600" dirty="0">
+                <a:solidFill>
+                  <a:schemeClr val="tx1"/>
+                </a:solidFill>
+              </a:rPr>
+            </a:br>
+            <a:endParaRPr lang="en-US" sz="3600" dirty="0">
               <a:solidFill>
-                <a:schemeClr val="bg1"/>
+                <a:schemeClr val="tx1"/>
               </a:solidFill>
             </a:endParaRPr>
+          </a:p>
+          <a:p>
+            <a:pPr marL="571500" indent="-571500">
+              <a:buFont typeface="Arial" panose="020B0604020202020204" pitchFamily="34" charset="0"/>
+              <a:buChar char="•"/>
+            </a:pPr>
+            <a:r>
+              <a:rPr lang="en-US" sz="3600" dirty="0">
+                <a:solidFill>
+                  <a:schemeClr val="tx1"/>
+                </a:solidFill>
+              </a:rPr>
+              <a:t>A reduced logistic regression model was then fitted solely using sex and BMI as predictors</a:t>
+            </a:r>
+          </a:p>
+          <a:p>
+            <a:pPr marL="1028700" lvl="1" indent="-571500">
+              <a:buFont typeface="Arial" panose="020B0604020202020204" pitchFamily="34" charset="0"/>
+              <a:buChar char="•"/>
+            </a:pPr>
+            <a:r>
+              <a:rPr lang="en-US" sz="3600" dirty="0">
+                <a:solidFill>
+                  <a:schemeClr val="tx1"/>
+                </a:solidFill>
+              </a:rPr>
+              <a:t>The test set misclassification error rate for the reduced model was 28.0%, slightly lower than that for the full model</a:t>
+            </a:r>
+            <a:br>
+              <a:rPr lang="en-US" sz="3600" dirty="0">
+                <a:solidFill>
+                  <a:schemeClr val="tx1"/>
+                </a:solidFill>
+              </a:rPr>
+            </a:br>
+            <a:endParaRPr lang="en-US" sz="3600" dirty="0">
+              <a:solidFill>
+                <a:schemeClr val="tx1"/>
+              </a:solidFill>
+            </a:endParaRPr>
+          </a:p>
+          <a:p>
+            <a:pPr marL="571500" indent="-571500">
+              <a:buFont typeface="Arial" panose="020B0604020202020204" pitchFamily="34" charset="0"/>
+              <a:buChar char="•"/>
+            </a:pPr>
+            <a:r>
+              <a:rPr lang="en-US" sz="3600" dirty="0">
+                <a:solidFill>
+                  <a:schemeClr val="tx1"/>
+                </a:solidFill>
+              </a:rPr>
+              <a:t>The results suggest that high-BMI or male patients should be paid greater attention to improve clinical outcomes</a:t>
+            </a:r>
+            <a:br>
+              <a:rPr lang="en-US" sz="3600" dirty="0">
+                <a:solidFill>
+                  <a:schemeClr val="tx1"/>
+                </a:solidFill>
+              </a:rPr>
+            </a:br>
+            <a:endParaRPr lang="en-US" sz="3600" dirty="0">
+              <a:solidFill>
+                <a:schemeClr val="tx1"/>
+              </a:solidFill>
+            </a:endParaRPr>
+          </a:p>
+          <a:p>
+            <a:pPr marL="571500" indent="-571500">
+              <a:buFont typeface="Arial" panose="020B0604020202020204" pitchFamily="34" charset="0"/>
+              <a:buChar char="•"/>
+            </a:pPr>
+            <a:r>
+              <a:rPr lang="en-US" sz="3600" dirty="0">
+                <a:solidFill>
+                  <a:schemeClr val="tx1"/>
+                </a:solidFill>
+              </a:rPr>
+              <a:t>Also, including more variables when modelling may not be clinically beneficial</a:t>
+            </a:r>
           </a:p>
         </p:txBody>
       </p:sp>
@@ -3186,7 +3346,7 @@
         </p:nvSpPr>
         <p:spPr>
           <a:xfrm>
-            <a:off x="0" y="12009120"/>
+            <a:off x="0" y="18494586"/>
             <a:ext cx="11765280" cy="1859280"/>
           </a:xfrm>
           <a:prstGeom prst="rect">
@@ -3240,8 +3400,8 @@
         </p:nvSpPr>
         <p:spPr>
           <a:xfrm>
-            <a:off x="0" y="13868400"/>
-            <a:ext cx="11765280" cy="18562320"/>
+            <a:off x="0" y="20353866"/>
+            <a:ext cx="11765280" cy="12076853"/>
           </a:xfrm>
           <a:prstGeom prst="rect">
             <a:avLst/>
@@ -3276,7 +3436,7 @@
               <a:buChar char="•"/>
             </a:pPr>
             <a:r>
-              <a:rPr lang="en-US" sz="4600" dirty="0">
+              <a:rPr lang="en-US" sz="3600" dirty="0">
                 <a:solidFill>
                   <a:schemeClr val="tx1"/>
                 </a:solidFill>
@@ -3284,7 +3444,7 @@
               <a:t>Postoperative hypoxemia is a frequent complication from anesthetic</a:t>
             </a:r>
             <a:r>
-              <a:rPr lang="en-US" sz="4600" baseline="30000" dirty="0">
+              <a:rPr lang="en-US" sz="3600" baseline="30000" dirty="0">
                 <a:solidFill>
                   <a:schemeClr val="tx1"/>
                 </a:solidFill>
@@ -3292,13 +3452,13 @@
               <a:t>1</a:t>
             </a:r>
             <a:br>
-              <a:rPr lang="en-US" sz="4600" dirty="0">
+              <a:rPr lang="en-US" sz="3600" dirty="0">
                 <a:solidFill>
                   <a:schemeClr val="tx1"/>
                 </a:solidFill>
               </a:rPr>
             </a:br>
-            <a:endParaRPr lang="en-US" sz="4600" dirty="0">
+            <a:endParaRPr lang="en-US" sz="3600" dirty="0">
               <a:solidFill>
                 <a:schemeClr val="tx1"/>
               </a:solidFill>
@@ -3310,7 +3470,7 @@
               <a:buChar char="•"/>
             </a:pPr>
             <a:r>
-              <a:rPr lang="en-US" sz="4600" dirty="0">
+              <a:rPr lang="en-US" sz="3600" dirty="0">
                 <a:solidFill>
                   <a:schemeClr val="tx1"/>
                 </a:solidFill>
@@ -3318,7 +3478,7 @@
               <a:t>The MOVER EPIC dataset includes records from 64,354 surgeries between 2017 and 2022</a:t>
             </a:r>
             <a:r>
-              <a:rPr lang="en-US" sz="4600" baseline="30000" dirty="0">
+              <a:rPr lang="en-US" sz="3600" baseline="30000" dirty="0">
                 <a:solidFill>
                   <a:schemeClr val="tx1"/>
                 </a:solidFill>
@@ -3326,7 +3486,7 @@
               <a:t>2</a:t>
             </a:r>
             <a:r>
-              <a:rPr lang="en-US" sz="4600" dirty="0">
+              <a:rPr lang="en-US" sz="3600" dirty="0">
                 <a:solidFill>
                   <a:schemeClr val="tx1"/>
                 </a:solidFill>
@@ -3334,13 +3494,13 @@
               <a:t> and can be used to study this issue</a:t>
             </a:r>
             <a:br>
-              <a:rPr lang="en-US" sz="4600" dirty="0">
+              <a:rPr lang="en-US" sz="3600" dirty="0">
                 <a:solidFill>
                   <a:schemeClr val="tx1"/>
                 </a:solidFill>
               </a:rPr>
             </a:br>
-            <a:endParaRPr lang="en-US" sz="4600" dirty="0">
+            <a:endParaRPr lang="en-US" sz="3600" dirty="0">
               <a:solidFill>
                 <a:schemeClr val="tx1"/>
               </a:solidFill>
@@ -3352,7 +3512,7 @@
               <a:buChar char="•"/>
             </a:pPr>
             <a:r>
-              <a:rPr lang="en-US" sz="4600" dirty="0">
+              <a:rPr lang="en-US" sz="3600" dirty="0">
                 <a:solidFill>
                   <a:schemeClr val="tx1"/>
                 </a:solidFill>
@@ -3360,7 +3520,7 @@
               <a:t>Prior research has assessed how postoperative hypoxemia is affected by different variables, but these models only contained up to four laboratory test results</a:t>
             </a:r>
             <a:r>
-              <a:rPr lang="en-US" sz="4600" baseline="30000" dirty="0">
+              <a:rPr lang="en-US" sz="3600" baseline="30000" dirty="0">
                 <a:solidFill>
                   <a:schemeClr val="tx1"/>
                 </a:solidFill>
@@ -3368,13 +3528,13 @@
               <a:t>3,4,5</a:t>
             </a:r>
             <a:br>
-              <a:rPr lang="en-US" sz="4600" dirty="0">
+              <a:rPr lang="en-US" sz="3600" dirty="0">
                 <a:solidFill>
                   <a:schemeClr val="tx1"/>
                 </a:solidFill>
               </a:rPr>
             </a:br>
-            <a:endParaRPr lang="en-US" sz="4600" dirty="0">
+            <a:endParaRPr lang="en-US" sz="3600" dirty="0">
               <a:solidFill>
                 <a:schemeClr val="tx1"/>
               </a:solidFill>
@@ -3386,7 +3546,7 @@
               <a:buChar char="•"/>
             </a:pPr>
             <a:r>
-              <a:rPr lang="en-US" sz="4600" dirty="0">
+              <a:rPr lang="en-US" sz="3600" dirty="0">
                 <a:solidFill>
                   <a:schemeClr val="tx1"/>
                 </a:solidFill>
@@ -3394,13 +3554,13 @@
               <a:t>To fill this gap characterized by few laboratory test results, this work modelled postoperative hypoxemia probability using logistic regression with up to ten preoperative laboratory test results and three demographic variables as covariates</a:t>
             </a:r>
             <a:br>
-              <a:rPr lang="en-US" sz="4600" dirty="0">
+              <a:rPr lang="en-US" sz="3600" dirty="0">
                 <a:solidFill>
                   <a:schemeClr val="tx1"/>
                 </a:solidFill>
               </a:rPr>
             </a:br>
-            <a:endParaRPr lang="en-US" sz="4600" dirty="0">
+            <a:endParaRPr lang="en-US" sz="3600" dirty="0">
               <a:solidFill>
                 <a:schemeClr val="tx1"/>
               </a:solidFill>
@@ -3412,7 +3572,7 @@
               <a:buChar char="•"/>
             </a:pPr>
             <a:r>
-              <a:rPr lang="en-US" sz="4600" dirty="0">
+              <a:rPr lang="en-US" sz="3600" dirty="0">
                 <a:solidFill>
                   <a:schemeClr val="tx1"/>
                 </a:solidFill>
@@ -3695,7 +3855,7 @@
                   <a:schemeClr val="tx1"/>
                 </a:solidFill>
               </a:rPr>
-              <a:t>Key Risk Factors of Postoperative hypoxemia</a:t>
+              <a:t>Key Risk Factors for Postoperative Hypoxemia</a:t>
             </a:r>
           </a:p>
           <a:p>
@@ -3810,7 +3970,7 @@
                   <a:schemeClr val="tx1"/>
                 </a:solidFill>
               </a:rPr>
-              <a:t>The reduced model outperforms the full model, suggesting that additional variables introduced noise rather than clinical signal</a:t>
+              <a:t>The reduced model outperformed the full model, suggesting that additional variables introduced noise rather than clinical signal</a:t>
             </a:r>
           </a:p>
           <a:p>
@@ -3824,23 +3984,7 @@
                   <a:schemeClr val="tx1"/>
                 </a:solidFill>
               </a:rPr>
-              <a:t>Only 98 out of 24,167 patients (0.4%) had hypoxemia. This extreme class imbalance limited model performance despite </a:t>
-            </a:r>
-            <a:r>
-              <a:rPr lang="en-CA" sz="3600" dirty="0" err="1">
-                <a:solidFill>
-                  <a:schemeClr val="tx1"/>
-                </a:solidFill>
-              </a:rPr>
-              <a:t>undersampling</a:t>
-            </a:r>
-            <a:r>
-              <a:rPr lang="en-CA" sz="3600" dirty="0">
-                <a:solidFill>
-                  <a:schemeClr val="tx1"/>
-                </a:solidFill>
-              </a:rPr>
-              <a:t> control cases to balance the data</a:t>
+              <a:t>Only 98 out of 24,167 entries (0.4%) had hypoxemia; this extreme class imbalance limited model performance despite undersampling control cases to balance the data</a:t>
             </a:r>
           </a:p>
           <a:p>
@@ -4335,7 +4479,7 @@
             <a:pPr algn="ctr"/>
             <a:r>
               <a:rPr lang="en-CA" sz="3400" dirty="0"/>
-              <a:t>Figure 1. Flow chart of data wrangling architecture</a:t>
+              <a:t>Figure 1. Flow chart of data wrangling architecture [CRP = C-reactive protein]</a:t>
             </a:r>
           </a:p>
         </p:txBody>
@@ -4392,8 +4536,8 @@
         </p:blipFill>
         <p:spPr>
           <a:xfrm>
-            <a:off x="12600000" y="19440000"/>
-            <a:ext cx="11520000" cy="8640000"/>
+            <a:off x="16661932" y="20072678"/>
+            <a:ext cx="10591727" cy="7644076"/>
           </a:xfrm>
           <a:prstGeom prst="rect">
             <a:avLst/>
@@ -4414,8 +4558,8 @@
         </p:nvSpPr>
         <p:spPr>
           <a:xfrm>
-            <a:off x="12600000" y="28080000"/>
-            <a:ext cx="11520000" cy="1138773"/>
+            <a:off x="16103160" y="19415570"/>
+            <a:ext cx="11520000" cy="615553"/>
           </a:xfrm>
           <a:prstGeom prst="rect">
             <a:avLst/>
@@ -4431,7 +4575,7 @@
             <a:pPr algn="ctr"/>
             <a:r>
               <a:rPr lang="en-CA" sz="3400" dirty="0"/>
-              <a:t>Table 1. Full logistic regression model results for postoperative hypoxemia</a:t>
+              <a:t>Table 1. Full logistic regression model results</a:t>
             </a:r>
           </a:p>
         </p:txBody>
@@ -4450,8 +4594,8 @@
         </p:nvSpPr>
         <p:spPr>
           <a:xfrm>
-            <a:off x="24190338" y="19473081"/>
-            <a:ext cx="7200000" cy="7540526"/>
+            <a:off x="12405360" y="27878360"/>
+            <a:ext cx="19080480" cy="4524315"/>
           </a:xfrm>
           <a:prstGeom prst="rect">
             <a:avLst/>
@@ -4459,7 +4603,7 @@
           <a:noFill/>
         </p:spPr>
         <p:txBody>
-          <a:bodyPr wrap="square" rtlCol="0">
+          <a:bodyPr wrap="square" rtlCol="0" anchor="ctr">
             <a:spAutoFit/>
           </a:bodyPr>
           <a:lstStyle/>
@@ -4469,16 +4613,26 @@
               <a:buChar char="•"/>
             </a:pPr>
             <a:r>
-              <a:rPr lang="en-CA" sz="4400" dirty="0"/>
-              <a:t>In the full model, sex and body mass index were the only predictors significant at the 0.05 level (Table 1).</a:t>
-            </a:r>
+              <a:rPr lang="en-CA" sz="3600" dirty="0"/>
+              <a:t>In the full model, sex and body mass index (BMI) were the only predictors significant at the 0.05 level (Table 1)</a:t>
+            </a:r>
+          </a:p>
+          <a:p>
+            <a:endParaRPr lang="en-CA" sz="3600" dirty="0"/>
           </a:p>
           <a:p>
             <a:pPr marL="571500" indent="-571500">
               <a:buFont typeface="Arial" panose="020B0604020202020204" pitchFamily="34" charset="0"/>
               <a:buChar char="•"/>
             </a:pPr>
-            <a:endParaRPr lang="en-CA" sz="4400" dirty="0"/>
+            <a:r>
+              <a:rPr lang="en-CA" sz="3600" dirty="0"/>
+              <a:t>Female sex and higher BMI were associated with lower and higher odds of postoperative hypoxemia, respectively</a:t>
+            </a:r>
+            <a:br>
+              <a:rPr lang="en-CA" sz="3600" dirty="0"/>
+            </a:br>
+            <a:endParaRPr lang="en-CA" sz="3600" dirty="0"/>
           </a:p>
           <a:p>
             <a:pPr marL="571500" indent="-571500">
@@ -4486,49 +4640,79 @@
               <a:buChar char="•"/>
             </a:pPr>
             <a:r>
-              <a:rPr lang="en-CA" sz="4400" dirty="0"/>
-              <a:t>Female sex is associated with lower odds of postoperative hypoxemia and higher body mass index associated with higher odds.</a:t>
-            </a:r>
-          </a:p>
-        </p:txBody>
-      </p:sp>
-      <p:sp>
-        <p:nvSpPr>
-          <p:cNvPr id="29" name="TextBox 28">
+              <a:rPr lang="en-CA" sz="3600" dirty="0"/>
+              <a:t>The reduced model, which included only sex and BMI as predictors, achieved a lower test set misclassification error rate (28.0%) than the full model (29.3%)</a:t>
+            </a:r>
+          </a:p>
+        </p:txBody>
+      </p:sp>
+      <p:sp>
+        <p:nvSpPr>
+          <p:cNvPr id="2" name="Rectangle 1">
             <a:extLst>
               <a:ext uri="{FF2B5EF4-FFF2-40B4-BE49-F238E27FC236}">
-                <a16:creationId xmlns:a16="http://schemas.microsoft.com/office/drawing/2014/main" id="{7A6DCCC3-3773-82B3-CC32-8929B10E1F37}"/>
+                <a16:creationId xmlns:a16="http://schemas.microsoft.com/office/drawing/2014/main" id="{0332F50C-0A29-A456-0797-DE2E587F2772}"/>
               </a:ext>
             </a:extLst>
           </p:cNvPr>
-          <p:cNvSpPr txBox="1"/>
+          <p:cNvSpPr/>
           <p:nvPr/>
         </p:nvSpPr>
         <p:spPr>
           <a:xfrm>
-            <a:off x="12405359" y="29429787"/>
-            <a:ext cx="19080479" cy="1323439"/>
+            <a:off x="0" y="32504453"/>
+            <a:ext cx="43891200" cy="418808"/>
           </a:xfrm>
           <a:prstGeom prst="rect">
             <a:avLst/>
           </a:prstGeom>
-          <a:noFill/>
+          <a:solidFill>
+            <a:schemeClr val="bg1"/>
+          </a:solidFill>
+          <a:ln w="25400"/>
         </p:spPr>
-        <p:txBody>
-          <a:bodyPr wrap="square" rtlCol="0">
-            <a:spAutoFit/>
-          </a:bodyPr>
-          <a:lstStyle/>
-          <a:p>
-            <a:pPr marL="285750" indent="-285750">
-              <a:buFont typeface="Arial" panose="020B0604020202020204" pitchFamily="34" charset="0"/>
-              <a:buChar char="•"/>
-            </a:pPr>
-            <a:r>
-              <a:rPr lang="en-CA" sz="4000" dirty="0"/>
-              <a:t>The reduced model, which included only sex and body mass index, achieved a lower test set misclassification rate (28.0%) than the full model (29.3%).</a:t>
-            </a:r>
-            <a:endParaRPr lang="en-CA" sz="3950" dirty="0"/>
+        <p:style>
+          <a:lnRef idx="2">
+            <a:schemeClr val="accent1">
+              <a:shade val="15000"/>
+            </a:schemeClr>
+          </a:lnRef>
+          <a:fillRef idx="1">
+            <a:schemeClr val="accent1"/>
+          </a:fillRef>
+          <a:effectRef idx="0">
+            <a:schemeClr val="accent1"/>
+          </a:effectRef>
+          <a:fontRef idx="minor">
+            <a:schemeClr val="lt1"/>
+          </a:fontRef>
+        </p:style>
+        <p:txBody>
+          <a:bodyPr rtlCol="0" anchor="ctr"/>
+          <a:lstStyle/>
+          <a:p>
+            <a:pPr algn="ctr"/>
+            <a:r>
+              <a:rPr lang="en-US" sz="2000" b="1" dirty="0">
+                <a:solidFill>
+                  <a:schemeClr val="tx1"/>
+                </a:solidFill>
+              </a:rPr>
+              <a:t>Generative AI:</a:t>
+            </a:r>
+            <a:r>
+              <a:rPr lang="en-US" sz="2000" dirty="0">
+                <a:solidFill>
+                  <a:schemeClr val="tx1"/>
+                </a:solidFill>
+              </a:rPr>
+              <a:t> Yang Lei refined writing using generative AI (ChatGPT). Benny Rochwerg used no generative AI tools. Yunfei Yu refined writing using generative AI (Gemini).</a:t>
+            </a:r>
+            <a:endParaRPr lang="en-US" sz="2000" b="1" dirty="0">
+              <a:solidFill>
+                <a:schemeClr val="tx1"/>
+              </a:solidFill>
+            </a:endParaRPr>
           </a:p>
         </p:txBody>
       </p:sp>

</xml_diff>